<commit_message>
updated ppt and report
</commit_message>
<xml_diff>
--- a/23AID312RL_TEAM10.pptx
+++ b/23AID312RL_TEAM10.pptx
@@ -45350,1635 +45350,13 @@
       </p:sp>
       <p:sp>
         <p:nvSpPr>
-          <p:cNvPr id="8" name="Shape 6"/>
-          <p:cNvSpPr/>
-          <p:nvPr/>
-        </p:nvSpPr>
-        <p:spPr>
-          <a:xfrm>
-            <a:off x="256032" y="658368"/>
-            <a:ext cx="1554480" cy="914400"/>
-          </a:xfrm>
-          <a:prstGeom prst="rect">
-            <a:avLst/>
-          </a:prstGeom>
-          <a:solidFill>
-            <a:srgbClr val="0D7377"/>
-          </a:solidFill>
-          <a:ln w="12700">
-            <a:solidFill>
-              <a:srgbClr val="0D7377"/>
-            </a:solidFill>
-            <a:prstDash val="solid"/>
-          </a:ln>
-          <a:effectLst>
-            <a:outerShdw blurRad="63500" dist="25400" dir="8100000" algn="bl" rotWithShape="0">
-              <a:srgbClr val="000000">
-                <a:alpha val="7000"/>
-              </a:srgbClr>
-            </a:outerShdw>
-          </a:effectLst>
-        </p:spPr>
-        <p:txBody>
-          <a:bodyPr/>
-          <a:lstStyle/>
-          <a:p>
-            <a:endParaRPr lang="en-IN"/>
-          </a:p>
-        </p:txBody>
-      </p:sp>
-      <p:sp>
-        <p:nvSpPr>
-          <p:cNvPr id="9" name="Text 7"/>
-          <p:cNvSpPr/>
-          <p:nvPr/>
-        </p:nvSpPr>
-        <p:spPr>
-          <a:xfrm>
-            <a:off x="320040" y="731520"/>
-            <a:ext cx="1426464" cy="402336"/>
-          </a:xfrm>
-          <a:prstGeom prst="rect">
-            <a:avLst/>
-          </a:prstGeom>
-          <a:noFill/>
-          <a:ln/>
-        </p:spPr>
-        <p:txBody>
-          <a:bodyPr wrap="square" lIns="0" tIns="0" rIns="0" bIns="0" rtlCol="0" anchor="ctr"/>
-          <a:lstStyle/>
-          <a:p>
-            <a:pPr marL="0" indent="0" algn="ctr">
-              <a:buNone/>
-            </a:pPr>
-            <a:r>
-              <a:rPr lang="en-US" sz="950" b="1" dirty="0">
-                <a:solidFill>
-                  <a:srgbClr val="FFFFFF"/>
-                </a:solidFill>
-                <a:latin typeface="Calibri" pitchFamily="34" charset="0"/>
-                <a:ea typeface="Calibri" pitchFamily="34" charset="-122"/>
-                <a:cs typeface="Calibri" pitchFamily="34" charset="-120"/>
-              </a:rPr>
-              <a:t>Warehouse</a:t>
-            </a:r>
-            <a:endParaRPr lang="en-US" sz="950" dirty="0"/>
-          </a:p>
-          <a:p>
-            <a:pPr marL="0" indent="0" algn="ctr">
-              <a:buNone/>
-            </a:pPr>
-            <a:r>
-              <a:rPr lang="en-US" sz="950" b="1" dirty="0">
-                <a:solidFill>
-                  <a:srgbClr val="FFFFFF"/>
-                </a:solidFill>
-                <a:latin typeface="Calibri" pitchFamily="34" charset="0"/>
-                <a:ea typeface="Calibri" pitchFamily="34" charset="-122"/>
-                <a:cs typeface="Calibri" pitchFamily="34" charset="-120"/>
-              </a:rPr>
-              <a:t>Environment</a:t>
-            </a:r>
-            <a:endParaRPr lang="en-US" sz="950" dirty="0"/>
-          </a:p>
-        </p:txBody>
-      </p:sp>
-      <p:sp>
-        <p:nvSpPr>
-          <p:cNvPr id="10" name="Text 8"/>
-          <p:cNvSpPr/>
-          <p:nvPr/>
-        </p:nvSpPr>
-        <p:spPr>
-          <a:xfrm>
-            <a:off x="320040" y="1161288"/>
-            <a:ext cx="1426464" cy="365760"/>
-          </a:xfrm>
-          <a:prstGeom prst="rect">
-            <a:avLst/>
-          </a:prstGeom>
-          <a:noFill/>
-          <a:ln/>
-        </p:spPr>
-        <p:txBody>
-          <a:bodyPr wrap="square" lIns="0" tIns="0" rIns="0" bIns="0" rtlCol="0" anchor="ctr"/>
-          <a:lstStyle/>
-          <a:p>
-            <a:pPr marL="0" indent="0" algn="ctr">
-              <a:buNone/>
-            </a:pPr>
-            <a:r>
-              <a:rPr lang="en-US" sz="780" dirty="0">
-                <a:solidFill>
-                  <a:srgbClr val="CEE8EC"/>
-                </a:solidFill>
-                <a:latin typeface="Calibri" pitchFamily="34" charset="0"/>
-                <a:ea typeface="Calibri" pitchFamily="34" charset="-122"/>
-                <a:cs typeface="Calibri" pitchFamily="34" charset="-120"/>
-              </a:rPr>
-              <a:t>5×7 grid · racks · goals</a:t>
-            </a:r>
-            <a:endParaRPr lang="en-US" sz="780" dirty="0"/>
-          </a:p>
-          <a:p>
-            <a:pPr marL="0" indent="0" algn="ctr">
-              <a:buNone/>
-            </a:pPr>
-            <a:r>
-              <a:rPr lang="en-US" sz="780" dirty="0">
-                <a:solidFill>
-                  <a:srgbClr val="CEE8EC"/>
-                </a:solidFill>
-                <a:latin typeface="Calibri" pitchFamily="34" charset="0"/>
-                <a:ea typeface="Calibri" pitchFamily="34" charset="-122"/>
-                <a:cs typeface="Calibri" pitchFamily="34" charset="-120"/>
-              </a:rPr>
-              <a:t>chargers · battery</a:t>
-            </a:r>
-            <a:endParaRPr lang="en-US" sz="780" dirty="0"/>
-          </a:p>
-        </p:txBody>
-      </p:sp>
-      <p:sp>
-        <p:nvSpPr>
-          <p:cNvPr id="11" name="Shape 9"/>
-          <p:cNvSpPr/>
-          <p:nvPr/>
-        </p:nvSpPr>
-        <p:spPr>
-          <a:xfrm>
-            <a:off x="1956816" y="658368"/>
-            <a:ext cx="1554480" cy="914400"/>
-          </a:xfrm>
-          <a:prstGeom prst="rect">
-            <a:avLst/>
-          </a:prstGeom>
-          <a:solidFill>
-            <a:srgbClr val="0F1F3D"/>
-          </a:solidFill>
-          <a:ln w="12700">
-            <a:solidFill>
-              <a:srgbClr val="0F1F3D"/>
-            </a:solidFill>
-            <a:prstDash val="solid"/>
-          </a:ln>
-          <a:effectLst>
-            <a:outerShdw blurRad="63500" dist="25400" dir="8100000" algn="bl" rotWithShape="0">
-              <a:srgbClr val="000000">
-                <a:alpha val="7000"/>
-              </a:srgbClr>
-            </a:outerShdw>
-          </a:effectLst>
-        </p:spPr>
-        <p:txBody>
-          <a:bodyPr/>
-          <a:lstStyle/>
-          <a:p>
-            <a:endParaRPr lang="en-IN"/>
-          </a:p>
-        </p:txBody>
-      </p:sp>
-      <p:sp>
-        <p:nvSpPr>
-          <p:cNvPr id="12" name="Text 10"/>
-          <p:cNvSpPr/>
-          <p:nvPr/>
-        </p:nvSpPr>
-        <p:spPr>
-          <a:xfrm>
-            <a:off x="2020824" y="731520"/>
-            <a:ext cx="1426464" cy="402336"/>
-          </a:xfrm>
-          <a:prstGeom prst="rect">
-            <a:avLst/>
-          </a:prstGeom>
-          <a:noFill/>
-          <a:ln/>
-        </p:spPr>
-        <p:txBody>
-          <a:bodyPr wrap="square" lIns="0" tIns="0" rIns="0" bIns="0" rtlCol="0" anchor="ctr"/>
-          <a:lstStyle/>
-          <a:p>
-            <a:pPr marL="0" indent="0" algn="ctr">
-              <a:buNone/>
-            </a:pPr>
-            <a:r>
-              <a:rPr lang="en-US" sz="950" b="1" dirty="0">
-                <a:solidFill>
-                  <a:srgbClr val="FFFFFF"/>
-                </a:solidFill>
-                <a:latin typeface="Calibri" pitchFamily="34" charset="0"/>
-                <a:ea typeface="Calibri" pitchFamily="34" charset="-122"/>
-                <a:cs typeface="Calibri" pitchFamily="34" charset="-120"/>
-              </a:rPr>
-              <a:t>Observation</a:t>
-            </a:r>
-            <a:endParaRPr lang="en-US" sz="950" dirty="0"/>
-          </a:p>
-          <a:p>
-            <a:pPr marL="0" indent="0" algn="ctr">
-              <a:buNone/>
-            </a:pPr>
-            <a:r>
-              <a:rPr lang="en-US" sz="950" b="1" dirty="0">
-                <a:solidFill>
-                  <a:srgbClr val="FFFFFF"/>
-                </a:solidFill>
-                <a:latin typeface="Calibri" pitchFamily="34" charset="0"/>
-                <a:ea typeface="Calibri" pitchFamily="34" charset="-122"/>
-                <a:cs typeface="Calibri" pitchFamily="34" charset="-120"/>
-              </a:rPr>
-              <a:t>Encoder</a:t>
-            </a:r>
-            <a:endParaRPr lang="en-US" sz="950" dirty="0"/>
-          </a:p>
-        </p:txBody>
-      </p:sp>
-      <p:sp>
-        <p:nvSpPr>
-          <p:cNvPr id="13" name="Text 11"/>
-          <p:cNvSpPr/>
-          <p:nvPr/>
-        </p:nvSpPr>
-        <p:spPr>
-          <a:xfrm>
-            <a:off x="2020824" y="1161288"/>
-            <a:ext cx="1426464" cy="365760"/>
-          </a:xfrm>
-          <a:prstGeom prst="rect">
-            <a:avLst/>
-          </a:prstGeom>
-          <a:noFill/>
-          <a:ln/>
-        </p:spPr>
-        <p:txBody>
-          <a:bodyPr wrap="square" lIns="0" tIns="0" rIns="0" bIns="0" rtlCol="0" anchor="ctr"/>
-          <a:lstStyle/>
-          <a:p>
-            <a:pPr marL="0" indent="0" algn="ctr">
-              <a:buNone/>
-            </a:pPr>
-            <a:r>
-              <a:rPr lang="en-US" sz="780" dirty="0">
-                <a:solidFill>
-                  <a:srgbClr val="CEE8EC"/>
-                </a:solidFill>
-                <a:latin typeface="Calibri" pitchFamily="34" charset="0"/>
-                <a:ea typeface="Calibri" pitchFamily="34" charset="-122"/>
-                <a:cs typeface="Calibri" pitchFamily="34" charset="-120"/>
-              </a:rPr>
-              <a:t>57-dim per agent</a:t>
-            </a:r>
-            <a:endParaRPr lang="en-US" sz="780" dirty="0"/>
-          </a:p>
-          <a:p>
-            <a:pPr marL="0" indent="0" algn="ctr">
-              <a:buNone/>
-            </a:pPr>
-            <a:r>
-              <a:rPr lang="en-US" sz="780" dirty="0">
-                <a:solidFill>
-                  <a:srgbClr val="CEE8EC"/>
-                </a:solidFill>
-                <a:latin typeface="Calibri" pitchFamily="34" charset="0"/>
-                <a:ea typeface="Calibri" pitchFamily="34" charset="-122"/>
-                <a:cs typeface="Calibri" pitchFamily="34" charset="-120"/>
-              </a:rPr>
-              <a:t>local view + orders</a:t>
-            </a:r>
-            <a:endParaRPr lang="en-US" sz="780" dirty="0"/>
-          </a:p>
-        </p:txBody>
-      </p:sp>
-      <p:sp>
-        <p:nvSpPr>
-          <p:cNvPr id="14" name="Shape 12"/>
-          <p:cNvSpPr/>
-          <p:nvPr/>
-        </p:nvSpPr>
-        <p:spPr>
-          <a:xfrm>
-            <a:off x="3657600" y="658368"/>
-            <a:ext cx="1554480" cy="914400"/>
-          </a:xfrm>
-          <a:prstGeom prst="rect">
-            <a:avLst/>
-          </a:prstGeom>
-          <a:solidFill>
-            <a:srgbClr val="1A2E4A"/>
-          </a:solidFill>
-          <a:ln w="12700">
-            <a:solidFill>
-              <a:srgbClr val="1A2E4A"/>
-            </a:solidFill>
-            <a:prstDash val="solid"/>
-          </a:ln>
-          <a:effectLst>
-            <a:outerShdw blurRad="63500" dist="25400" dir="8100000" algn="bl" rotWithShape="0">
-              <a:srgbClr val="000000">
-                <a:alpha val="7000"/>
-              </a:srgbClr>
-            </a:outerShdw>
-          </a:effectLst>
-        </p:spPr>
-        <p:txBody>
-          <a:bodyPr/>
-          <a:lstStyle/>
-          <a:p>
-            <a:endParaRPr lang="en-IN"/>
-          </a:p>
-        </p:txBody>
-      </p:sp>
-      <p:sp>
-        <p:nvSpPr>
-          <p:cNvPr id="15" name="Text 13"/>
-          <p:cNvSpPr/>
-          <p:nvPr/>
-        </p:nvSpPr>
-        <p:spPr>
-          <a:xfrm>
-            <a:off x="3721608" y="731520"/>
-            <a:ext cx="1426464" cy="402336"/>
-          </a:xfrm>
-          <a:prstGeom prst="rect">
-            <a:avLst/>
-          </a:prstGeom>
-          <a:noFill/>
-          <a:ln/>
-        </p:spPr>
-        <p:txBody>
-          <a:bodyPr wrap="square" lIns="0" tIns="0" rIns="0" bIns="0" rtlCol="0" anchor="ctr"/>
-          <a:lstStyle/>
-          <a:p>
-            <a:pPr marL="0" indent="0" algn="ctr">
-              <a:buNone/>
-            </a:pPr>
-            <a:r>
-              <a:rPr lang="en-US" sz="950" b="1" dirty="0">
-                <a:solidFill>
-                  <a:srgbClr val="FFFFFF"/>
-                </a:solidFill>
-                <a:latin typeface="Calibri" pitchFamily="34" charset="0"/>
-                <a:ea typeface="Calibri" pitchFamily="34" charset="-122"/>
-                <a:cs typeface="Calibri" pitchFamily="34" charset="-120"/>
-              </a:rPr>
-              <a:t>Dueling DQN</a:t>
-            </a:r>
-            <a:endParaRPr lang="en-US" sz="950" dirty="0"/>
-          </a:p>
-          <a:p>
-            <a:pPr marL="0" indent="0" algn="ctr">
-              <a:buNone/>
-            </a:pPr>
-            <a:r>
-              <a:rPr lang="en-US" sz="950" b="1" dirty="0">
-                <a:solidFill>
-                  <a:srgbClr val="FFFFFF"/>
-                </a:solidFill>
-                <a:latin typeface="Calibri" pitchFamily="34" charset="0"/>
-                <a:ea typeface="Calibri" pitchFamily="34" charset="-122"/>
-                <a:cs typeface="Calibri" pitchFamily="34" charset="-120"/>
-              </a:rPr>
-              <a:t>Network</a:t>
-            </a:r>
-            <a:endParaRPr lang="en-US" sz="950" dirty="0"/>
-          </a:p>
-        </p:txBody>
-      </p:sp>
-      <p:sp>
-        <p:nvSpPr>
-          <p:cNvPr id="16" name="Text 14"/>
-          <p:cNvSpPr/>
-          <p:nvPr/>
-        </p:nvSpPr>
-        <p:spPr>
-          <a:xfrm>
-            <a:off x="3721608" y="1161288"/>
-            <a:ext cx="1426464" cy="365760"/>
-          </a:xfrm>
-          <a:prstGeom prst="rect">
-            <a:avLst/>
-          </a:prstGeom>
-          <a:noFill/>
-          <a:ln/>
-        </p:spPr>
-        <p:txBody>
-          <a:bodyPr wrap="square" lIns="0" tIns="0" rIns="0" bIns="0" rtlCol="0" anchor="ctr"/>
-          <a:lstStyle/>
-          <a:p>
-            <a:pPr marL="0" indent="0" algn="ctr">
-              <a:buNone/>
-            </a:pPr>
-            <a:r>
-              <a:rPr lang="en-US" sz="780" dirty="0">
-                <a:solidFill>
-                  <a:srgbClr val="CEE8EC"/>
-                </a:solidFill>
-                <a:latin typeface="Calibri" pitchFamily="34" charset="0"/>
-                <a:ea typeface="Calibri" pitchFamily="34" charset="-122"/>
-                <a:cs typeface="Calibri" pitchFamily="34" charset="-120"/>
-              </a:rPr>
-              <a:t>Shared backbone</a:t>
-            </a:r>
-            <a:endParaRPr lang="en-US" sz="780" dirty="0"/>
-          </a:p>
-          <a:p>
-            <a:pPr marL="0" indent="0" algn="ctr">
-              <a:buNone/>
-            </a:pPr>
-            <a:r>
-              <a:rPr lang="en-US" sz="780" dirty="0">
-                <a:solidFill>
-                  <a:srgbClr val="CEE8EC"/>
-                </a:solidFill>
-                <a:latin typeface="Calibri" pitchFamily="34" charset="0"/>
-                <a:ea typeface="Calibri" pitchFamily="34" charset="-122"/>
-                <a:cs typeface="Calibri" pitchFamily="34" charset="-120"/>
-              </a:rPr>
-              <a:t>V+A → Q(s,a)</a:t>
-            </a:r>
-            <a:endParaRPr lang="en-US" sz="780" dirty="0"/>
-          </a:p>
-        </p:txBody>
-      </p:sp>
-      <p:sp>
-        <p:nvSpPr>
-          <p:cNvPr id="17" name="Shape 15"/>
-          <p:cNvSpPr/>
-          <p:nvPr/>
-        </p:nvSpPr>
-        <p:spPr>
-          <a:xfrm>
-            <a:off x="3657600" y="1737360"/>
-            <a:ext cx="1554480" cy="914400"/>
-          </a:xfrm>
-          <a:prstGeom prst="rect">
-            <a:avLst/>
-          </a:prstGeom>
-          <a:solidFill>
-            <a:srgbClr val="3D5166"/>
-          </a:solidFill>
-          <a:ln w="12700">
-            <a:solidFill>
-              <a:srgbClr val="3D5166"/>
-            </a:solidFill>
-            <a:prstDash val="solid"/>
-          </a:ln>
-          <a:effectLst>
-            <a:outerShdw blurRad="63500" dist="25400" dir="8100000" algn="bl" rotWithShape="0">
-              <a:srgbClr val="000000">
-                <a:alpha val="7000"/>
-              </a:srgbClr>
-            </a:outerShdw>
-          </a:effectLst>
-        </p:spPr>
-        <p:txBody>
-          <a:bodyPr/>
-          <a:lstStyle/>
-          <a:p>
-            <a:endParaRPr lang="en-IN"/>
-          </a:p>
-        </p:txBody>
-      </p:sp>
-      <p:sp>
-        <p:nvSpPr>
-          <p:cNvPr id="18" name="Text 16"/>
-          <p:cNvSpPr/>
-          <p:nvPr/>
-        </p:nvSpPr>
-        <p:spPr>
-          <a:xfrm>
-            <a:off x="3721608" y="1810512"/>
-            <a:ext cx="1426464" cy="402336"/>
-          </a:xfrm>
-          <a:prstGeom prst="rect">
-            <a:avLst/>
-          </a:prstGeom>
-          <a:noFill/>
-          <a:ln/>
-        </p:spPr>
-        <p:txBody>
-          <a:bodyPr wrap="square" lIns="0" tIns="0" rIns="0" bIns="0" rtlCol="0" anchor="ctr"/>
-          <a:lstStyle/>
-          <a:p>
-            <a:pPr marL="0" indent="0" algn="ctr">
-              <a:buNone/>
-            </a:pPr>
-            <a:r>
-              <a:rPr lang="en-US" sz="950" b="1" dirty="0">
-                <a:solidFill>
-                  <a:srgbClr val="FFFFFF"/>
-                </a:solidFill>
-                <a:latin typeface="Calibri" pitchFamily="34" charset="0"/>
-                <a:ea typeface="Calibri" pitchFamily="34" charset="-122"/>
-                <a:cs typeface="Calibri" pitchFamily="34" charset="-120"/>
-              </a:rPr>
-              <a:t>Replay</a:t>
-            </a:r>
-            <a:endParaRPr lang="en-US" sz="950" dirty="0"/>
-          </a:p>
-          <a:p>
-            <a:pPr marL="0" indent="0" algn="ctr">
-              <a:buNone/>
-            </a:pPr>
-            <a:r>
-              <a:rPr lang="en-US" sz="950" b="1" dirty="0">
-                <a:solidFill>
-                  <a:srgbClr val="FFFFFF"/>
-                </a:solidFill>
-                <a:latin typeface="Calibri" pitchFamily="34" charset="0"/>
-                <a:ea typeface="Calibri" pitchFamily="34" charset="-122"/>
-                <a:cs typeface="Calibri" pitchFamily="34" charset="-120"/>
-              </a:rPr>
-              <a:t>Buffer</a:t>
-            </a:r>
-            <a:endParaRPr lang="en-US" sz="950" dirty="0"/>
-          </a:p>
-        </p:txBody>
-      </p:sp>
-      <p:sp>
-        <p:nvSpPr>
-          <p:cNvPr id="19" name="Text 17"/>
-          <p:cNvSpPr/>
-          <p:nvPr/>
-        </p:nvSpPr>
-        <p:spPr>
-          <a:xfrm>
-            <a:off x="3721608" y="2240280"/>
-            <a:ext cx="1426464" cy="365760"/>
-          </a:xfrm>
-          <a:prstGeom prst="rect">
-            <a:avLst/>
-          </a:prstGeom>
-          <a:noFill/>
-          <a:ln/>
-        </p:spPr>
-        <p:txBody>
-          <a:bodyPr wrap="square" lIns="0" tIns="0" rIns="0" bIns="0" rtlCol="0" anchor="ctr"/>
-          <a:lstStyle/>
-          <a:p>
-            <a:pPr marL="0" indent="0" algn="ctr">
-              <a:buNone/>
-            </a:pPr>
-            <a:r>
-              <a:rPr lang="en-US" sz="780" dirty="0">
-                <a:solidFill>
-                  <a:srgbClr val="CEE8EC"/>
-                </a:solidFill>
-                <a:latin typeface="Calibri" pitchFamily="34" charset="0"/>
-                <a:ea typeface="Calibri" pitchFamily="34" charset="-122"/>
-                <a:cs typeface="Calibri" pitchFamily="34" charset="-120"/>
-              </a:rPr>
-              <a:t>30k transitions</a:t>
-            </a:r>
-            <a:endParaRPr lang="en-US" sz="780" dirty="0"/>
-          </a:p>
-          <a:p>
-            <a:pPr marL="0" indent="0" algn="ctr">
-              <a:buNone/>
-            </a:pPr>
-            <a:r>
-              <a:rPr lang="en-US" sz="780" dirty="0">
-                <a:solidFill>
-                  <a:srgbClr val="CEE8EC"/>
-                </a:solidFill>
-                <a:latin typeface="Calibri" pitchFamily="34" charset="0"/>
-                <a:ea typeface="Calibri" pitchFamily="34" charset="-122"/>
-                <a:cs typeface="Calibri" pitchFamily="34" charset="-120"/>
-              </a:rPr>
-              <a:t>uniform sampling</a:t>
-            </a:r>
-            <a:endParaRPr lang="en-US" sz="780" dirty="0"/>
-          </a:p>
-        </p:txBody>
-      </p:sp>
-      <p:sp>
-        <p:nvSpPr>
-          <p:cNvPr id="20" name="Shape 18"/>
-          <p:cNvSpPr/>
-          <p:nvPr/>
-        </p:nvSpPr>
-        <p:spPr>
-          <a:xfrm>
-            <a:off x="1956816" y="1737360"/>
-            <a:ext cx="1554480" cy="914400"/>
-          </a:xfrm>
-          <a:prstGeom prst="rect">
-            <a:avLst/>
-          </a:prstGeom>
-          <a:solidFill>
-            <a:srgbClr val="0D7377"/>
-          </a:solidFill>
-          <a:ln w="12700">
-            <a:solidFill>
-              <a:srgbClr val="0D7377"/>
-            </a:solidFill>
-            <a:prstDash val="solid"/>
-          </a:ln>
-          <a:effectLst>
-            <a:outerShdw blurRad="63500" dist="25400" dir="8100000" algn="bl" rotWithShape="0">
-              <a:srgbClr val="000000">
-                <a:alpha val="7000"/>
-              </a:srgbClr>
-            </a:outerShdw>
-          </a:effectLst>
-        </p:spPr>
-        <p:txBody>
-          <a:bodyPr/>
-          <a:lstStyle/>
-          <a:p>
-            <a:endParaRPr lang="en-IN"/>
-          </a:p>
-        </p:txBody>
-      </p:sp>
-      <p:sp>
-        <p:nvSpPr>
-          <p:cNvPr id="21" name="Text 19"/>
-          <p:cNvSpPr/>
-          <p:nvPr/>
-        </p:nvSpPr>
-        <p:spPr>
-          <a:xfrm>
-            <a:off x="2020824" y="1810512"/>
-            <a:ext cx="1426464" cy="402336"/>
-          </a:xfrm>
-          <a:prstGeom prst="rect">
-            <a:avLst/>
-          </a:prstGeom>
-          <a:noFill/>
-          <a:ln/>
-        </p:spPr>
-        <p:txBody>
-          <a:bodyPr wrap="square" lIns="0" tIns="0" rIns="0" bIns="0" rtlCol="0" anchor="ctr"/>
-          <a:lstStyle/>
-          <a:p>
-            <a:pPr marL="0" indent="0" algn="ctr">
-              <a:buNone/>
-            </a:pPr>
-            <a:r>
-              <a:rPr lang="en-US" sz="950" b="1" dirty="0">
-                <a:solidFill>
-                  <a:srgbClr val="FFFFFF"/>
-                </a:solidFill>
-                <a:latin typeface="Calibri" pitchFamily="34" charset="0"/>
-                <a:ea typeface="Calibri" pitchFamily="34" charset="-122"/>
-                <a:cs typeface="Calibri" pitchFamily="34" charset="-120"/>
-              </a:rPr>
-              <a:t>Policy</a:t>
-            </a:r>
-            <a:endParaRPr lang="en-US" sz="950" dirty="0"/>
-          </a:p>
-          <a:p>
-            <a:pPr marL="0" indent="0" algn="ctr">
-              <a:buNone/>
-            </a:pPr>
-            <a:r>
-              <a:rPr lang="en-US" sz="950" b="1" dirty="0">
-                <a:solidFill>
-                  <a:srgbClr val="FFFFFF"/>
-                </a:solidFill>
-                <a:latin typeface="Calibri" pitchFamily="34" charset="0"/>
-                <a:ea typeface="Calibri" pitchFamily="34" charset="-122"/>
-                <a:cs typeface="Calibri" pitchFamily="34" charset="-120"/>
-              </a:rPr>
-              <a:t>Execution</a:t>
-            </a:r>
-            <a:endParaRPr lang="en-US" sz="950" dirty="0"/>
-          </a:p>
-        </p:txBody>
-      </p:sp>
-      <p:sp>
-        <p:nvSpPr>
-          <p:cNvPr id="22" name="Text 20"/>
-          <p:cNvSpPr/>
-          <p:nvPr/>
-        </p:nvSpPr>
-        <p:spPr>
-          <a:xfrm>
-            <a:off x="2020824" y="2240280"/>
-            <a:ext cx="1426464" cy="365760"/>
-          </a:xfrm>
-          <a:prstGeom prst="rect">
-            <a:avLst/>
-          </a:prstGeom>
-          <a:noFill/>
-          <a:ln/>
-        </p:spPr>
-        <p:txBody>
-          <a:bodyPr wrap="square" lIns="0" tIns="0" rIns="0" bIns="0" rtlCol="0" anchor="ctr"/>
-          <a:lstStyle/>
-          <a:p>
-            <a:pPr marL="0" indent="0" algn="ctr">
-              <a:buNone/>
-            </a:pPr>
-            <a:r>
-              <a:rPr lang="en-US" sz="780" dirty="0">
-                <a:solidFill>
-                  <a:srgbClr val="CEE8EC"/>
-                </a:solidFill>
-                <a:latin typeface="Calibri" pitchFamily="34" charset="0"/>
-                <a:ea typeface="Calibri" pitchFamily="34" charset="-122"/>
-                <a:cs typeface="Calibri" pitchFamily="34" charset="-120"/>
-              </a:rPr>
-              <a:t>ε-greedy actions</a:t>
-            </a:r>
-            <a:endParaRPr lang="en-US" sz="780" dirty="0"/>
-          </a:p>
-          <a:p>
-            <a:pPr marL="0" indent="0" algn="ctr">
-              <a:buNone/>
-            </a:pPr>
-            <a:r>
-              <a:rPr lang="en-US" sz="780" dirty="0">
-                <a:solidFill>
-                  <a:srgbClr val="CEE8EC"/>
-                </a:solidFill>
-                <a:latin typeface="Calibri" pitchFamily="34" charset="0"/>
-                <a:ea typeface="Calibri" pitchFamily="34" charset="-122"/>
-                <a:cs typeface="Calibri" pitchFamily="34" charset="-120"/>
-              </a:rPr>
-              <a:t>train / eval modes</a:t>
-            </a:r>
-            <a:endParaRPr lang="en-US" sz="780" dirty="0"/>
-          </a:p>
-        </p:txBody>
-      </p:sp>
-      <p:sp>
-        <p:nvSpPr>
-          <p:cNvPr id="23" name="Shape 21"/>
-          <p:cNvSpPr/>
-          <p:nvPr/>
-        </p:nvSpPr>
-        <p:spPr>
-          <a:xfrm>
-            <a:off x="256032" y="1737360"/>
-            <a:ext cx="1554480" cy="914400"/>
-          </a:xfrm>
-          <a:prstGeom prst="rect">
-            <a:avLst/>
-          </a:prstGeom>
-          <a:solidFill>
-            <a:srgbClr val="6B8899"/>
-          </a:solidFill>
-          <a:ln w="12700">
-            <a:solidFill>
-              <a:srgbClr val="6B8899"/>
-            </a:solidFill>
-            <a:prstDash val="solid"/>
-          </a:ln>
-          <a:effectLst>
-            <a:outerShdw blurRad="63500" dist="25400" dir="8100000" algn="bl" rotWithShape="0">
-              <a:srgbClr val="000000">
-                <a:alpha val="7000"/>
-              </a:srgbClr>
-            </a:outerShdw>
-          </a:effectLst>
-        </p:spPr>
-        <p:txBody>
-          <a:bodyPr/>
-          <a:lstStyle/>
-          <a:p>
-            <a:endParaRPr lang="en-IN"/>
-          </a:p>
-        </p:txBody>
-      </p:sp>
-      <p:sp>
-        <p:nvSpPr>
-          <p:cNvPr id="24" name="Text 22"/>
-          <p:cNvSpPr/>
-          <p:nvPr/>
-        </p:nvSpPr>
-        <p:spPr>
-          <a:xfrm>
-            <a:off x="320040" y="1810512"/>
-            <a:ext cx="1426464" cy="402336"/>
-          </a:xfrm>
-          <a:prstGeom prst="rect">
-            <a:avLst/>
-          </a:prstGeom>
-          <a:noFill/>
-          <a:ln/>
-        </p:spPr>
-        <p:txBody>
-          <a:bodyPr wrap="square" lIns="0" tIns="0" rIns="0" bIns="0" rtlCol="0" anchor="ctr"/>
-          <a:lstStyle/>
-          <a:p>
-            <a:pPr marL="0" indent="0" algn="ctr">
-              <a:buNone/>
-            </a:pPr>
-            <a:r>
-              <a:rPr lang="en-US" sz="950" b="1" dirty="0">
-                <a:solidFill>
-                  <a:srgbClr val="FFFFFF"/>
-                </a:solidFill>
-                <a:latin typeface="Calibri" pitchFamily="34" charset="0"/>
-                <a:ea typeface="Calibri" pitchFamily="34" charset="-122"/>
-                <a:cs typeface="Calibri" pitchFamily="34" charset="-120"/>
-              </a:rPr>
-              <a:t>Metrics</a:t>
-            </a:r>
-            <a:endParaRPr lang="en-US" sz="950" dirty="0"/>
-          </a:p>
-          <a:p>
-            <a:pPr marL="0" indent="0" algn="ctr">
-              <a:buNone/>
-            </a:pPr>
-            <a:r>
-              <a:rPr lang="en-US" sz="950" b="1" dirty="0">
-                <a:solidFill>
-                  <a:srgbClr val="FFFFFF"/>
-                </a:solidFill>
-                <a:latin typeface="Calibri" pitchFamily="34" charset="0"/>
-                <a:ea typeface="Calibri" pitchFamily="34" charset="-122"/>
-                <a:cs typeface="Calibri" pitchFamily="34" charset="-120"/>
-              </a:rPr>
-              <a:t>Logger</a:t>
-            </a:r>
-            <a:endParaRPr lang="en-US" sz="950" dirty="0"/>
-          </a:p>
-        </p:txBody>
-      </p:sp>
-      <p:sp>
-        <p:nvSpPr>
-          <p:cNvPr id="25" name="Text 23"/>
-          <p:cNvSpPr/>
-          <p:nvPr/>
-        </p:nvSpPr>
-        <p:spPr>
-          <a:xfrm>
-            <a:off x="320040" y="2240280"/>
-            <a:ext cx="1426464" cy="365760"/>
-          </a:xfrm>
-          <a:prstGeom prst="rect">
-            <a:avLst/>
-          </a:prstGeom>
-          <a:noFill/>
-          <a:ln/>
-        </p:spPr>
-        <p:txBody>
-          <a:bodyPr wrap="square" lIns="0" tIns="0" rIns="0" bIns="0" rtlCol="0" anchor="ctr"/>
-          <a:lstStyle/>
-          <a:p>
-            <a:pPr marL="0" indent="0" algn="ctr">
-              <a:buNone/>
-            </a:pPr>
-            <a:r>
-              <a:rPr lang="en-US" sz="780" dirty="0">
-                <a:solidFill>
-                  <a:srgbClr val="CEE8EC"/>
-                </a:solidFill>
-                <a:latin typeface="Calibri" pitchFamily="34" charset="0"/>
-                <a:ea typeface="Calibri" pitchFamily="34" charset="-122"/>
-                <a:cs typeface="Calibri" pitchFamily="34" charset="-120"/>
-              </a:rPr>
-              <a:t>JSON + TensorBoard</a:t>
-            </a:r>
-            <a:endParaRPr lang="en-US" sz="780" dirty="0"/>
-          </a:p>
-          <a:p>
-            <a:pPr marL="0" indent="0" algn="ctr">
-              <a:buNone/>
-            </a:pPr>
-            <a:r>
-              <a:rPr lang="en-US" sz="780" dirty="0">
-                <a:solidFill>
-                  <a:srgbClr val="CEE8EC"/>
-                </a:solidFill>
-                <a:latin typeface="Calibri" pitchFamily="34" charset="0"/>
-                <a:ea typeface="Calibri" pitchFamily="34" charset="-122"/>
-                <a:cs typeface="Calibri" pitchFamily="34" charset="-120"/>
-              </a:rPr>
-              <a:t>Plot artifacts</a:t>
-            </a:r>
-            <a:endParaRPr lang="en-US" sz="780" dirty="0"/>
-          </a:p>
-        </p:txBody>
-      </p:sp>
-      <p:sp>
-        <p:nvSpPr>
-          <p:cNvPr id="26" name="Shape 24"/>
-          <p:cNvSpPr/>
-          <p:nvPr/>
-        </p:nvSpPr>
-        <p:spPr>
-          <a:xfrm>
-            <a:off x="256032" y="2816352"/>
-            <a:ext cx="1554480" cy="914400"/>
-          </a:xfrm>
-          <a:prstGeom prst="rect">
-            <a:avLst/>
-          </a:prstGeom>
-          <a:solidFill>
-            <a:srgbClr val="F0A500"/>
-          </a:solidFill>
-          <a:ln w="12700">
-            <a:solidFill>
-              <a:srgbClr val="F0A500"/>
-            </a:solidFill>
-            <a:prstDash val="solid"/>
-          </a:ln>
-          <a:effectLst>
-            <a:outerShdw blurRad="63500" dist="25400" dir="8100000" algn="bl" rotWithShape="0">
-              <a:srgbClr val="000000">
-                <a:alpha val="7000"/>
-              </a:srgbClr>
-            </a:outerShdw>
-          </a:effectLst>
-        </p:spPr>
-        <p:txBody>
-          <a:bodyPr/>
-          <a:lstStyle/>
-          <a:p>
-            <a:endParaRPr lang="en-IN"/>
-          </a:p>
-        </p:txBody>
-      </p:sp>
-      <p:sp>
-        <p:nvSpPr>
-          <p:cNvPr id="27" name="Text 25"/>
-          <p:cNvSpPr/>
-          <p:nvPr/>
-        </p:nvSpPr>
-        <p:spPr>
-          <a:xfrm>
-            <a:off x="320040" y="2889504"/>
-            <a:ext cx="1426464" cy="402336"/>
-          </a:xfrm>
-          <a:prstGeom prst="rect">
-            <a:avLst/>
-          </a:prstGeom>
-          <a:noFill/>
-          <a:ln/>
-        </p:spPr>
-        <p:txBody>
-          <a:bodyPr wrap="square" lIns="0" tIns="0" rIns="0" bIns="0" rtlCol="0" anchor="ctr"/>
-          <a:lstStyle/>
-          <a:p>
-            <a:pPr marL="0" indent="0" algn="ctr">
-              <a:buNone/>
-            </a:pPr>
-            <a:r>
-              <a:rPr lang="en-US" sz="950" b="1" dirty="0">
-                <a:solidFill>
-                  <a:srgbClr val="FFFFFF"/>
-                </a:solidFill>
-                <a:latin typeface="Calibri" pitchFamily="34" charset="0"/>
-                <a:ea typeface="Calibri" pitchFamily="34" charset="-122"/>
-                <a:cs typeface="Calibri" pitchFamily="34" charset="-120"/>
-              </a:rPr>
-              <a:t>Streamlit</a:t>
-            </a:r>
-            <a:endParaRPr lang="en-US" sz="950" dirty="0"/>
-          </a:p>
-          <a:p>
-            <a:pPr marL="0" indent="0" algn="ctr">
-              <a:buNone/>
-            </a:pPr>
-            <a:r>
-              <a:rPr lang="en-US" sz="950" b="1" dirty="0">
-                <a:solidFill>
-                  <a:srgbClr val="FFFFFF"/>
-                </a:solidFill>
-                <a:latin typeface="Calibri" pitchFamily="34" charset="0"/>
-                <a:ea typeface="Calibri" pitchFamily="34" charset="-122"/>
-                <a:cs typeface="Calibri" pitchFamily="34" charset="-120"/>
-              </a:rPr>
-              <a:t>Dashboard</a:t>
-            </a:r>
-            <a:endParaRPr lang="en-US" sz="950" dirty="0"/>
-          </a:p>
-        </p:txBody>
-      </p:sp>
-      <p:sp>
-        <p:nvSpPr>
-          <p:cNvPr id="28" name="Text 26"/>
-          <p:cNvSpPr/>
-          <p:nvPr/>
-        </p:nvSpPr>
-        <p:spPr>
-          <a:xfrm>
-            <a:off x="320040" y="3319272"/>
-            <a:ext cx="1426464" cy="365760"/>
-          </a:xfrm>
-          <a:prstGeom prst="rect">
-            <a:avLst/>
-          </a:prstGeom>
-          <a:noFill/>
-          <a:ln/>
-        </p:spPr>
-        <p:txBody>
-          <a:bodyPr wrap="square" lIns="0" tIns="0" rIns="0" bIns="0" rtlCol="0" anchor="ctr"/>
-          <a:lstStyle/>
-          <a:p>
-            <a:pPr marL="0" indent="0" algn="ctr">
-              <a:buNone/>
-            </a:pPr>
-            <a:r>
-              <a:rPr lang="en-US" sz="780" dirty="0">
-                <a:solidFill>
-                  <a:srgbClr val="0D1117"/>
-                </a:solidFill>
-                <a:latin typeface="Calibri" pitchFamily="34" charset="0"/>
-                <a:ea typeface="Calibri" pitchFamily="34" charset="-122"/>
-                <a:cs typeface="Calibri" pitchFamily="34" charset="-120"/>
-              </a:rPr>
-              <a:t>Live animation</a:t>
-            </a:r>
-            <a:endParaRPr lang="en-US" sz="780" dirty="0"/>
-          </a:p>
-          <a:p>
-            <a:pPr marL="0" indent="0" algn="ctr">
-              <a:buNone/>
-            </a:pPr>
-            <a:r>
-              <a:rPr lang="en-US" sz="780" dirty="0">
-                <a:solidFill>
-                  <a:srgbClr val="0D1117"/>
-                </a:solidFill>
-                <a:latin typeface="Calibri" pitchFamily="34" charset="0"/>
-                <a:ea typeface="Calibri" pitchFamily="34" charset="-122"/>
-                <a:cs typeface="Calibri" pitchFamily="34" charset="-120"/>
-              </a:rPr>
-              <a:t>Policy comparison</a:t>
-            </a:r>
-            <a:endParaRPr lang="en-US" sz="780" dirty="0"/>
-          </a:p>
-        </p:txBody>
-      </p:sp>
-      <p:sp>
-        <p:nvSpPr>
-          <p:cNvPr id="29" name="Shape 27"/>
-          <p:cNvSpPr/>
-          <p:nvPr/>
-        </p:nvSpPr>
-        <p:spPr>
-          <a:xfrm>
-            <a:off x="1956816" y="2816352"/>
-            <a:ext cx="1554480" cy="914400"/>
-          </a:xfrm>
-          <a:prstGeom prst="rect">
-            <a:avLst/>
-          </a:prstGeom>
-          <a:solidFill>
-            <a:srgbClr val="888888"/>
-          </a:solidFill>
-          <a:ln w="12700">
-            <a:solidFill>
-              <a:srgbClr val="888888"/>
-            </a:solidFill>
-            <a:prstDash val="solid"/>
-          </a:ln>
-          <a:effectLst>
-            <a:outerShdw blurRad="63500" dist="25400" dir="8100000" algn="bl" rotWithShape="0">
-              <a:srgbClr val="000000">
-                <a:alpha val="7000"/>
-              </a:srgbClr>
-            </a:outerShdw>
-          </a:effectLst>
-        </p:spPr>
-        <p:txBody>
-          <a:bodyPr/>
-          <a:lstStyle/>
-          <a:p>
-            <a:endParaRPr lang="en-IN"/>
-          </a:p>
-        </p:txBody>
-      </p:sp>
-      <p:sp>
-        <p:nvSpPr>
-          <p:cNvPr id="30" name="Text 28"/>
-          <p:cNvSpPr/>
-          <p:nvPr/>
-        </p:nvSpPr>
-        <p:spPr>
-          <a:xfrm>
-            <a:off x="2020824" y="2889504"/>
-            <a:ext cx="1426464" cy="402336"/>
-          </a:xfrm>
-          <a:prstGeom prst="rect">
-            <a:avLst/>
-          </a:prstGeom>
-          <a:noFill/>
-          <a:ln/>
-        </p:spPr>
-        <p:txBody>
-          <a:bodyPr wrap="square" lIns="0" tIns="0" rIns="0" bIns="0" rtlCol="0" anchor="ctr"/>
-          <a:lstStyle/>
-          <a:p>
-            <a:pPr marL="0" indent="0" algn="ctr">
-              <a:buNone/>
-            </a:pPr>
-            <a:r>
-              <a:rPr lang="en-US" sz="950" b="1" dirty="0">
-                <a:solidFill>
-                  <a:srgbClr val="FFFFFF"/>
-                </a:solidFill>
-                <a:latin typeface="Calibri" pitchFamily="34" charset="0"/>
-                <a:ea typeface="Calibri" pitchFamily="34" charset="-122"/>
-                <a:cs typeface="Calibri" pitchFamily="34" charset="-120"/>
-              </a:rPr>
-              <a:t>Greedy</a:t>
-            </a:r>
-            <a:endParaRPr lang="en-US" sz="950" dirty="0"/>
-          </a:p>
-          <a:p>
-            <a:pPr marL="0" indent="0" algn="ctr">
-              <a:buNone/>
-            </a:pPr>
-            <a:r>
-              <a:rPr lang="en-US" sz="950" b="1" dirty="0">
-                <a:solidFill>
-                  <a:srgbClr val="FFFFFF"/>
-                </a:solidFill>
-                <a:latin typeface="Calibri" pitchFamily="34" charset="0"/>
-                <a:ea typeface="Calibri" pitchFamily="34" charset="-122"/>
-                <a:cs typeface="Calibri" pitchFamily="34" charset="-120"/>
-              </a:rPr>
-              <a:t>Baseline</a:t>
-            </a:r>
-            <a:endParaRPr lang="en-US" sz="950" dirty="0"/>
-          </a:p>
-        </p:txBody>
-      </p:sp>
-      <p:sp>
-        <p:nvSpPr>
-          <p:cNvPr id="31" name="Text 29"/>
-          <p:cNvSpPr/>
-          <p:nvPr/>
-        </p:nvSpPr>
-        <p:spPr>
-          <a:xfrm>
-            <a:off x="2020824" y="3319272"/>
-            <a:ext cx="1426464" cy="365760"/>
-          </a:xfrm>
-          <a:prstGeom prst="rect">
-            <a:avLst/>
-          </a:prstGeom>
-          <a:noFill/>
-          <a:ln/>
-        </p:spPr>
-        <p:txBody>
-          <a:bodyPr wrap="square" lIns="0" tIns="0" rIns="0" bIns="0" rtlCol="0" anchor="ctr"/>
-          <a:lstStyle/>
-          <a:p>
-            <a:pPr marL="0" indent="0" algn="ctr">
-              <a:buNone/>
-            </a:pPr>
-            <a:r>
-              <a:rPr lang="en-US" sz="780" dirty="0">
-                <a:solidFill>
-                  <a:srgbClr val="CEE8EC"/>
-                </a:solidFill>
-                <a:latin typeface="Calibri" pitchFamily="34" charset="0"/>
-                <a:ea typeface="Calibri" pitchFamily="34" charset="-122"/>
-                <a:cs typeface="Calibri" pitchFamily="34" charset="-120"/>
-              </a:rPr>
-              <a:t>Manhattan-distance</a:t>
-            </a:r>
-            <a:endParaRPr lang="en-US" sz="780" dirty="0"/>
-          </a:p>
-          <a:p>
-            <a:pPr marL="0" indent="0" algn="ctr">
-              <a:buNone/>
-            </a:pPr>
-            <a:r>
-              <a:rPr lang="en-US" sz="780" dirty="0">
-                <a:solidFill>
-                  <a:srgbClr val="CEE8EC"/>
-                </a:solidFill>
-                <a:latin typeface="Calibri" pitchFamily="34" charset="0"/>
-                <a:ea typeface="Calibri" pitchFamily="34" charset="-122"/>
-                <a:cs typeface="Calibri" pitchFamily="34" charset="-120"/>
-              </a:rPr>
-              <a:t>heuristic</a:t>
-            </a:r>
-            <a:endParaRPr lang="en-US" sz="780" dirty="0"/>
-          </a:p>
-        </p:txBody>
-      </p:sp>
-      <p:sp>
-        <p:nvSpPr>
-          <p:cNvPr id="32" name="Shape 30"/>
-          <p:cNvSpPr/>
-          <p:nvPr/>
-        </p:nvSpPr>
-        <p:spPr>
-          <a:xfrm>
-            <a:off x="3657600" y="2816352"/>
-            <a:ext cx="1554480" cy="914400"/>
-          </a:xfrm>
-          <a:prstGeom prst="rect">
-            <a:avLst/>
-          </a:prstGeom>
-          <a:solidFill>
-            <a:srgbClr val="1E6B45"/>
-          </a:solidFill>
-          <a:ln w="12700">
-            <a:solidFill>
-              <a:srgbClr val="1E6B45"/>
-            </a:solidFill>
-            <a:prstDash val="solid"/>
-          </a:ln>
-          <a:effectLst>
-            <a:outerShdw blurRad="63500" dist="25400" dir="8100000" algn="bl" rotWithShape="0">
-              <a:srgbClr val="000000">
-                <a:alpha val="7000"/>
-              </a:srgbClr>
-            </a:outerShdw>
-          </a:effectLst>
-        </p:spPr>
-        <p:txBody>
-          <a:bodyPr/>
-          <a:lstStyle/>
-          <a:p>
-            <a:endParaRPr lang="en-IN"/>
-          </a:p>
-        </p:txBody>
-      </p:sp>
-      <p:sp>
-        <p:nvSpPr>
-          <p:cNvPr id="33" name="Text 31"/>
-          <p:cNvSpPr/>
-          <p:nvPr/>
-        </p:nvSpPr>
-        <p:spPr>
-          <a:xfrm>
-            <a:off x="3721608" y="2889504"/>
-            <a:ext cx="1426464" cy="402336"/>
-          </a:xfrm>
-          <a:prstGeom prst="rect">
-            <a:avLst/>
-          </a:prstGeom>
-          <a:noFill/>
-          <a:ln/>
-        </p:spPr>
-        <p:txBody>
-          <a:bodyPr wrap="square" lIns="0" tIns="0" rIns="0" bIns="0" rtlCol="0" anchor="ctr"/>
-          <a:lstStyle/>
-          <a:p>
-            <a:pPr marL="0" indent="0" algn="ctr">
-              <a:buNone/>
-            </a:pPr>
-            <a:r>
-              <a:rPr lang="en-US" sz="950" b="1" dirty="0">
-                <a:solidFill>
-                  <a:srgbClr val="FFFFFF"/>
-                </a:solidFill>
-                <a:latin typeface="Calibri" pitchFamily="34" charset="0"/>
-                <a:ea typeface="Calibri" pitchFamily="34" charset="-122"/>
-                <a:cs typeface="Calibri" pitchFamily="34" charset="-120"/>
-              </a:rPr>
-              <a:t>Evaluation</a:t>
-            </a:r>
-            <a:endParaRPr lang="en-US" sz="950" dirty="0"/>
-          </a:p>
-          <a:p>
-            <a:pPr marL="0" indent="0" algn="ctr">
-              <a:buNone/>
-            </a:pPr>
-            <a:r>
-              <a:rPr lang="en-US" sz="950" b="1" dirty="0">
-                <a:solidFill>
-                  <a:srgbClr val="FFFFFF"/>
-                </a:solidFill>
-                <a:latin typeface="Calibri" pitchFamily="34" charset="0"/>
-                <a:ea typeface="Calibri" pitchFamily="34" charset="-122"/>
-                <a:cs typeface="Calibri" pitchFamily="34" charset="-120"/>
-              </a:rPr>
-              <a:t>Report</a:t>
-            </a:r>
-            <a:endParaRPr lang="en-US" sz="950" dirty="0"/>
-          </a:p>
-        </p:txBody>
-      </p:sp>
-      <p:sp>
-        <p:nvSpPr>
-          <p:cNvPr id="34" name="Text 32"/>
-          <p:cNvSpPr/>
-          <p:nvPr/>
-        </p:nvSpPr>
-        <p:spPr>
-          <a:xfrm>
-            <a:off x="3721608" y="3319272"/>
-            <a:ext cx="1426464" cy="365760"/>
-          </a:xfrm>
-          <a:prstGeom prst="rect">
-            <a:avLst/>
-          </a:prstGeom>
-          <a:noFill/>
-          <a:ln/>
-        </p:spPr>
-        <p:txBody>
-          <a:bodyPr wrap="square" lIns="0" tIns="0" rIns="0" bIns="0" rtlCol="0" anchor="ctr"/>
-          <a:lstStyle/>
-          <a:p>
-            <a:pPr marL="0" indent="0" algn="ctr">
-              <a:buNone/>
-            </a:pPr>
-            <a:r>
-              <a:rPr lang="en-US" sz="780" dirty="0">
-                <a:solidFill>
-                  <a:srgbClr val="CEE8EC"/>
-                </a:solidFill>
-                <a:latin typeface="Calibri" pitchFamily="34" charset="0"/>
-                <a:ea typeface="Calibri" pitchFamily="34" charset="-122"/>
-                <a:cs typeface="Calibri" pitchFamily="34" charset="-120"/>
-              </a:rPr>
-              <a:t>DQN vs Greedy</a:t>
-            </a:r>
-            <a:endParaRPr lang="en-US" sz="780" dirty="0"/>
-          </a:p>
-          <a:p>
-            <a:pPr marL="0" indent="0" algn="ctr">
-              <a:buNone/>
-            </a:pPr>
-            <a:r>
-              <a:rPr lang="en-US" sz="780" dirty="0">
-                <a:solidFill>
-                  <a:srgbClr val="CEE8EC"/>
-                </a:solidFill>
-                <a:latin typeface="Calibri" pitchFamily="34" charset="0"/>
-                <a:ea typeface="Calibri" pitchFamily="34" charset="-122"/>
-                <a:cs typeface="Calibri" pitchFamily="34" charset="-120"/>
-              </a:rPr>
-              <a:t>vs Random</a:t>
-            </a:r>
-            <a:endParaRPr lang="en-US" sz="780" dirty="0"/>
-          </a:p>
-        </p:txBody>
-      </p:sp>
-      <p:sp>
-        <p:nvSpPr>
-          <p:cNvPr id="35" name="Shape 33"/>
-          <p:cNvSpPr/>
-          <p:nvPr/>
-        </p:nvSpPr>
-        <p:spPr>
-          <a:xfrm>
-            <a:off x="1810512" y="1042416"/>
-            <a:ext cx="274320" cy="146304"/>
-          </a:xfrm>
-          <a:prstGeom prst="rightArrow">
-            <a:avLst/>
-          </a:prstGeom>
-          <a:solidFill>
-            <a:srgbClr val="0D7377"/>
-          </a:solidFill>
-          <a:ln w="12700">
-            <a:solidFill>
-              <a:srgbClr val="0D7377"/>
-            </a:solidFill>
-            <a:prstDash val="solid"/>
-          </a:ln>
-        </p:spPr>
-        <p:txBody>
-          <a:bodyPr/>
-          <a:lstStyle/>
-          <a:p>
-            <a:endParaRPr lang="en-IN"/>
-          </a:p>
-        </p:txBody>
-      </p:sp>
-      <p:sp>
-        <p:nvSpPr>
-          <p:cNvPr id="36" name="Shape 34"/>
-          <p:cNvSpPr/>
-          <p:nvPr/>
-        </p:nvSpPr>
-        <p:spPr>
-          <a:xfrm>
-            <a:off x="3511296" y="1042416"/>
-            <a:ext cx="274320" cy="146304"/>
-          </a:xfrm>
-          <a:prstGeom prst="rightArrow">
-            <a:avLst/>
-          </a:prstGeom>
-          <a:solidFill>
-            <a:srgbClr val="0D7377"/>
-          </a:solidFill>
-          <a:ln w="12700">
-            <a:solidFill>
-              <a:srgbClr val="0D7377"/>
-            </a:solidFill>
-            <a:prstDash val="solid"/>
-          </a:ln>
-        </p:spPr>
-        <p:txBody>
-          <a:bodyPr/>
-          <a:lstStyle/>
-          <a:p>
-            <a:endParaRPr lang="en-IN"/>
-          </a:p>
-        </p:txBody>
-      </p:sp>
-      <p:sp>
-        <p:nvSpPr>
-          <p:cNvPr id="37" name="Shape 35"/>
-          <p:cNvSpPr/>
-          <p:nvPr/>
-        </p:nvSpPr>
-        <p:spPr>
-          <a:xfrm>
-            <a:off x="4361688" y="1572768"/>
-            <a:ext cx="146304" cy="164592"/>
-          </a:xfrm>
-          <a:prstGeom prst="downArrow">
-            <a:avLst/>
-          </a:prstGeom>
-          <a:solidFill>
-            <a:srgbClr val="0D7377"/>
-          </a:solidFill>
-          <a:ln w="12700">
-            <a:solidFill>
-              <a:srgbClr val="0D7377"/>
-            </a:solidFill>
-            <a:prstDash val="solid"/>
-          </a:ln>
-        </p:spPr>
-        <p:txBody>
-          <a:bodyPr/>
-          <a:lstStyle/>
-          <a:p>
-            <a:endParaRPr lang="en-IN"/>
-          </a:p>
-        </p:txBody>
-      </p:sp>
-      <p:sp>
-        <p:nvSpPr>
-          <p:cNvPr id="38" name="Shape 36"/>
-          <p:cNvSpPr/>
-          <p:nvPr/>
-        </p:nvSpPr>
-        <p:spPr>
-          <a:xfrm>
-            <a:off x="3511296" y="2121408"/>
-            <a:ext cx="274320" cy="146304"/>
-          </a:xfrm>
-          <a:prstGeom prst="leftArrow">
-            <a:avLst/>
-          </a:prstGeom>
-          <a:solidFill>
-            <a:srgbClr val="0D7377"/>
-          </a:solidFill>
-          <a:ln w="12700">
-            <a:solidFill>
-              <a:srgbClr val="0D7377"/>
-            </a:solidFill>
-            <a:prstDash val="solid"/>
-          </a:ln>
-        </p:spPr>
-        <p:txBody>
-          <a:bodyPr/>
-          <a:lstStyle/>
-          <a:p>
-            <a:endParaRPr lang="en-IN"/>
-          </a:p>
-        </p:txBody>
-      </p:sp>
-      <p:sp>
-        <p:nvSpPr>
-          <p:cNvPr id="39" name="Shape 37"/>
-          <p:cNvSpPr/>
-          <p:nvPr/>
-        </p:nvSpPr>
-        <p:spPr>
-          <a:xfrm>
-            <a:off x="1810512" y="2121408"/>
-            <a:ext cx="274320" cy="146304"/>
-          </a:xfrm>
-          <a:prstGeom prst="leftArrow">
-            <a:avLst/>
-          </a:prstGeom>
-          <a:solidFill>
-            <a:srgbClr val="0D7377"/>
-          </a:solidFill>
-          <a:ln w="12700">
-            <a:solidFill>
-              <a:srgbClr val="0D7377"/>
-            </a:solidFill>
-            <a:prstDash val="solid"/>
-          </a:ln>
-        </p:spPr>
-        <p:txBody>
-          <a:bodyPr/>
-          <a:lstStyle/>
-          <a:p>
-            <a:endParaRPr lang="en-IN"/>
-          </a:p>
-        </p:txBody>
-      </p:sp>
-      <p:sp>
-        <p:nvSpPr>
-          <p:cNvPr id="40" name="Shape 38"/>
-          <p:cNvSpPr/>
-          <p:nvPr/>
-        </p:nvSpPr>
-        <p:spPr>
-          <a:xfrm>
-            <a:off x="960120" y="2651760"/>
-            <a:ext cx="146304" cy="164592"/>
-          </a:xfrm>
-          <a:prstGeom prst="downArrow">
-            <a:avLst/>
-          </a:prstGeom>
-          <a:solidFill>
-            <a:srgbClr val="0D7377"/>
-          </a:solidFill>
-          <a:ln w="12700">
-            <a:solidFill>
-              <a:srgbClr val="0D7377"/>
-            </a:solidFill>
-            <a:prstDash val="solid"/>
-          </a:ln>
-        </p:spPr>
-        <p:txBody>
-          <a:bodyPr/>
-          <a:lstStyle/>
-          <a:p>
-            <a:endParaRPr lang="en-IN"/>
-          </a:p>
-        </p:txBody>
-      </p:sp>
-      <p:sp>
-        <p:nvSpPr>
-          <p:cNvPr id="41" name="Shape 39"/>
-          <p:cNvSpPr/>
-          <p:nvPr/>
-        </p:nvSpPr>
-        <p:spPr>
-          <a:xfrm>
-            <a:off x="3511296" y="3200400"/>
-            <a:ext cx="274320" cy="146304"/>
-          </a:xfrm>
-          <a:prstGeom prst="rightArrow">
-            <a:avLst/>
-          </a:prstGeom>
-          <a:solidFill>
-            <a:srgbClr val="0D7377"/>
-          </a:solidFill>
-          <a:ln w="12700">
-            <a:solidFill>
-              <a:srgbClr val="0D7377"/>
-            </a:solidFill>
-            <a:prstDash val="solid"/>
-          </a:ln>
-        </p:spPr>
-        <p:txBody>
-          <a:bodyPr/>
-          <a:lstStyle/>
-          <a:p>
-            <a:endParaRPr lang="en-IN"/>
-          </a:p>
-        </p:txBody>
-      </p:sp>
-      <p:sp>
-        <p:nvSpPr>
-          <p:cNvPr id="43" name="Text 41"/>
-          <p:cNvSpPr/>
-          <p:nvPr/>
-        </p:nvSpPr>
-        <p:spPr>
-          <a:xfrm>
-            <a:off x="4233672" y="1426464"/>
-            <a:ext cx="347472" cy="182880"/>
-          </a:xfrm>
-          <a:prstGeom prst="rect">
-            <a:avLst/>
-          </a:prstGeom>
-          <a:noFill/>
-          <a:ln/>
-        </p:spPr>
-        <p:txBody>
-          <a:bodyPr wrap="square" lIns="0" tIns="0" rIns="0" bIns="0" rtlCol="0" anchor="ctr"/>
-          <a:lstStyle/>
-          <a:p>
-            <a:pPr marL="0" indent="0">
-              <a:buNone/>
-            </a:pPr>
-            <a:r>
-              <a:rPr lang="en-US" sz="650" dirty="0">
-                <a:solidFill>
-                  <a:srgbClr val="6B8899"/>
-                </a:solidFill>
-                <a:latin typeface="Calibri" pitchFamily="34" charset="0"/>
-                <a:ea typeface="Calibri" pitchFamily="34" charset="-122"/>
-                <a:cs typeface="Calibri" pitchFamily="34" charset="-120"/>
-              </a:rPr>
-              <a:t>acts</a:t>
-            </a:r>
-            <a:endParaRPr lang="en-US" sz="650" dirty="0"/>
-          </a:p>
-        </p:txBody>
-      </p:sp>
-      <p:sp>
-        <p:nvSpPr>
           <p:cNvPr id="44" name="Shape 42"/>
           <p:cNvSpPr/>
           <p:nvPr/>
         </p:nvSpPr>
         <p:spPr>
           <a:xfrm>
-            <a:off x="5486400" y="658368"/>
+            <a:off x="5705856" y="998525"/>
             <a:ext cx="3401568" cy="3127248"/>
           </a:xfrm>
           <a:prstGeom prst="rect">
@@ -47017,7 +45395,7 @@
         </p:nvSpPr>
         <p:spPr>
           <a:xfrm>
-            <a:off x="5486400" y="658368"/>
+            <a:off x="5705856" y="998525"/>
             <a:ext cx="3401568" cy="43891"/>
           </a:xfrm>
           <a:prstGeom prst="rect">
@@ -47049,7 +45427,7 @@
         </p:nvSpPr>
         <p:spPr>
           <a:xfrm>
-            <a:off x="5614416" y="768096"/>
+            <a:off x="5833872" y="1108253"/>
             <a:ext cx="3200400" cy="274320"/>
           </a:xfrm>
           <a:prstGeom prst="rect">
@@ -47088,7 +45466,7 @@
         </p:nvSpPr>
         <p:spPr>
           <a:xfrm>
-            <a:off x="5614416" y="1143000"/>
+            <a:off x="5833872" y="1483157"/>
             <a:ext cx="50292" cy="548640"/>
           </a:xfrm>
           <a:prstGeom prst="rect">
@@ -47120,7 +45498,7 @@
         </p:nvSpPr>
         <p:spPr>
           <a:xfrm>
-            <a:off x="5705856" y="1179576"/>
+            <a:off x="5925312" y="1519733"/>
             <a:ext cx="3090672" cy="237744"/>
           </a:xfrm>
           <a:prstGeom prst="rect">
@@ -47159,7 +45537,7 @@
         </p:nvSpPr>
         <p:spPr>
           <a:xfrm>
-            <a:off x="5705856" y="1417320"/>
+            <a:off x="5925312" y="1757477"/>
             <a:ext cx="3090672" cy="274320"/>
           </a:xfrm>
           <a:prstGeom prst="rect">
@@ -47198,7 +45576,7 @@
         </p:nvSpPr>
         <p:spPr>
           <a:xfrm>
-            <a:off x="5614416" y="1801368"/>
+            <a:off x="5833872" y="2141525"/>
             <a:ext cx="50292" cy="548640"/>
           </a:xfrm>
           <a:prstGeom prst="rect">
@@ -47230,7 +45608,7 @@
         </p:nvSpPr>
         <p:spPr>
           <a:xfrm>
-            <a:off x="5705856" y="1837944"/>
+            <a:off x="5925312" y="2178101"/>
             <a:ext cx="3090672" cy="237744"/>
           </a:xfrm>
           <a:prstGeom prst="rect">
@@ -47269,7 +45647,7 @@
         </p:nvSpPr>
         <p:spPr>
           <a:xfrm>
-            <a:off x="5705856" y="2075688"/>
+            <a:off x="5925312" y="2415845"/>
             <a:ext cx="3090672" cy="274320"/>
           </a:xfrm>
           <a:prstGeom prst="rect">
@@ -47308,7 +45686,7 @@
         </p:nvSpPr>
         <p:spPr>
           <a:xfrm>
-            <a:off x="5614416" y="2459736"/>
+            <a:off x="5833872" y="2799893"/>
             <a:ext cx="50292" cy="548640"/>
           </a:xfrm>
           <a:prstGeom prst="rect">
@@ -47340,7 +45718,7 @@
         </p:nvSpPr>
         <p:spPr>
           <a:xfrm>
-            <a:off x="5705856" y="2496312"/>
+            <a:off x="5925312" y="2836469"/>
             <a:ext cx="3090672" cy="237744"/>
           </a:xfrm>
           <a:prstGeom prst="rect">
@@ -47379,7 +45757,7 @@
         </p:nvSpPr>
         <p:spPr>
           <a:xfrm>
-            <a:off x="5705856" y="2734056"/>
+            <a:off x="5925312" y="3074213"/>
             <a:ext cx="3090672" cy="274320"/>
           </a:xfrm>
           <a:prstGeom prst="rect">
@@ -47418,7 +45796,7 @@
         </p:nvSpPr>
         <p:spPr>
           <a:xfrm>
-            <a:off x="5614416" y="3118104"/>
+            <a:off x="5833872" y="3458261"/>
             <a:ext cx="50292" cy="548640"/>
           </a:xfrm>
           <a:prstGeom prst="rect">
@@ -47450,7 +45828,7 @@
         </p:nvSpPr>
         <p:spPr>
           <a:xfrm>
-            <a:off x="5705856" y="3154680"/>
+            <a:off x="5925312" y="3494837"/>
             <a:ext cx="3090672" cy="237744"/>
           </a:xfrm>
           <a:prstGeom prst="rect">
@@ -47489,7 +45867,7 @@
         </p:nvSpPr>
         <p:spPr>
           <a:xfrm>
-            <a:off x="5705856" y="3392424"/>
+            <a:off x="5925312" y="3732581"/>
             <a:ext cx="3090672" cy="274320"/>
           </a:xfrm>
           <a:prstGeom prst="rect">
@@ -47520,161 +45898,36 @@
           </a:p>
         </p:txBody>
       </p:sp>
-      <p:sp>
-        <p:nvSpPr>
-          <p:cNvPr id="59" name="Text 57"/>
-          <p:cNvSpPr/>
-          <p:nvPr/>
-        </p:nvSpPr>
-        <p:spPr>
-          <a:xfrm rot="16200000">
-            <a:off x="5198364" y="962862"/>
-            <a:ext cx="320040" cy="274320"/>
-          </a:xfrm>
-          <a:prstGeom prst="rect">
-            <a:avLst/>
-          </a:prstGeom>
-          <a:noFill/>
-          <a:ln/>
-        </p:spPr>
-        <p:txBody>
-          <a:bodyPr wrap="square" lIns="0" tIns="0" rIns="0" bIns="0" rtlCol="0" anchor="ctr"/>
-          <a:lstStyle/>
-          <a:p>
-            <a:pPr marL="0" indent="0" algn="ctr">
-              <a:buNone/>
-            </a:pPr>
-            <a:r>
-              <a:rPr lang="en-US" sz="650" b="1" dirty="0">
-                <a:solidFill>
-                  <a:srgbClr val="0D7377"/>
-                </a:solidFill>
-                <a:latin typeface="Calibri" pitchFamily="34" charset="0"/>
-                <a:ea typeface="Calibri" pitchFamily="34" charset="-122"/>
-                <a:cs typeface="Calibri" pitchFamily="34" charset="-120"/>
-              </a:rPr>
-              <a:t>① Interact</a:t>
-            </a:r>
-            <a:endParaRPr lang="en-US" sz="650" dirty="0"/>
-          </a:p>
-        </p:txBody>
-      </p:sp>
-      <p:sp>
-        <p:nvSpPr>
-          <p:cNvPr id="60" name="Text 58"/>
-          <p:cNvSpPr/>
-          <p:nvPr/>
-        </p:nvSpPr>
-        <p:spPr>
-          <a:xfrm rot="16200000">
-            <a:off x="5193792" y="2043684"/>
-            <a:ext cx="310896" cy="274320"/>
-          </a:xfrm>
-          <a:prstGeom prst="rect">
-            <a:avLst/>
-          </a:prstGeom>
-          <a:noFill/>
-          <a:ln/>
-        </p:spPr>
-        <p:txBody>
-          <a:bodyPr wrap="square" lIns="0" tIns="0" rIns="0" bIns="0" rtlCol="0" anchor="ctr"/>
-          <a:lstStyle/>
-          <a:p>
-            <a:pPr marL="0" indent="0" algn="ctr">
-              <a:buNone/>
-            </a:pPr>
-            <a:r>
-              <a:rPr lang="en-US" sz="650" b="1" dirty="0">
-                <a:solidFill>
-                  <a:srgbClr val="0D7377"/>
-                </a:solidFill>
-                <a:latin typeface="Calibri" pitchFamily="34" charset="0"/>
-                <a:ea typeface="Calibri" pitchFamily="34" charset="-122"/>
-                <a:cs typeface="Calibri" pitchFamily="34" charset="-120"/>
-              </a:rPr>
-              <a:t>② Learn</a:t>
-            </a:r>
-            <a:endParaRPr lang="en-US" sz="650" dirty="0"/>
-          </a:p>
-        </p:txBody>
-      </p:sp>
-      <p:sp>
-        <p:nvSpPr>
-          <p:cNvPr id="61" name="Text 59"/>
-          <p:cNvSpPr/>
-          <p:nvPr/>
-        </p:nvSpPr>
-        <p:spPr>
-          <a:xfrm rot="16200000">
-            <a:off x="5145786" y="3115818"/>
-            <a:ext cx="406908" cy="274320"/>
-          </a:xfrm>
-          <a:prstGeom prst="rect">
-            <a:avLst/>
-          </a:prstGeom>
-          <a:noFill/>
-          <a:ln/>
-        </p:spPr>
-        <p:txBody>
-          <a:bodyPr wrap="square" lIns="0" tIns="0" rIns="0" bIns="0" rtlCol="0" anchor="ctr"/>
-          <a:lstStyle/>
-          <a:p>
-            <a:pPr marL="0" indent="0" algn="ctr">
-              <a:buNone/>
-            </a:pPr>
-            <a:r>
-              <a:rPr lang="en-US" sz="650" b="1" dirty="0">
-                <a:solidFill>
-                  <a:srgbClr val="0D7377"/>
-                </a:solidFill>
-                <a:latin typeface="Calibri" pitchFamily="34" charset="0"/>
-                <a:ea typeface="Calibri" pitchFamily="34" charset="-122"/>
-                <a:cs typeface="Calibri" pitchFamily="34" charset="-120"/>
-              </a:rPr>
-              <a:t>③ Evaluate</a:t>
-            </a:r>
-            <a:endParaRPr lang="en-US" sz="650" dirty="0"/>
-          </a:p>
-        </p:txBody>
-      </p:sp>
-      <p:sp>
-        <p:nvSpPr>
-          <p:cNvPr id="65" name="Shape 33">
+      <p:pic>
+        <p:nvPicPr>
+          <p:cNvPr id="62" name="Picture 61">
             <a:extLst>
               <a:ext uri="{FF2B5EF4-FFF2-40B4-BE49-F238E27FC236}">
-                <a16:creationId xmlns:a16="http://schemas.microsoft.com/office/drawing/2014/main" id="{1B28A8E1-5183-09C8-57EC-DF04DF7D41E9}"/>
+                <a16:creationId xmlns:a16="http://schemas.microsoft.com/office/drawing/2014/main" id="{76589DB3-CB67-DD0F-6FAA-ED7431F2E813}"/>
               </a:ext>
             </a:extLst>
           </p:cNvPr>
-          <p:cNvSpPr/>
-          <p:nvPr/>
-        </p:nvSpPr>
-        <p:spPr>
-          <a:xfrm>
-            <a:off x="1780794" y="3179825"/>
-            <a:ext cx="274320" cy="146304"/>
-          </a:xfrm>
-          <a:prstGeom prst="rightArrow">
-            <a:avLst/>
-          </a:prstGeom>
-          <a:solidFill>
-            <a:srgbClr val="0D7377"/>
-          </a:solidFill>
-          <a:ln w="12700">
-            <a:solidFill>
-              <a:srgbClr val="0D7377"/>
-            </a:solidFill>
-            <a:prstDash val="solid"/>
-          </a:ln>
-        </p:spPr>
-        <p:txBody>
-          <a:bodyPr/>
-          <a:lstStyle/>
-          <a:p>
-            <a:endParaRPr lang="en-IN"/>
-          </a:p>
-        </p:txBody>
-      </p:sp>
+          <p:cNvPicPr>
+            <a:picLocks noChangeAspect="1"/>
+          </p:cNvPicPr>
+          <p:nvPr/>
+        </p:nvPicPr>
+        <p:blipFill>
+          <a:blip r:embed="rId3"/>
+          <a:stretch>
+            <a:fillRect/>
+          </a:stretch>
+        </p:blipFill>
+        <p:spPr>
+          <a:xfrm>
+            <a:off x="76742" y="1036889"/>
+            <a:ext cx="5608540" cy="2610612"/>
+          </a:xfrm>
+          <a:prstGeom prst="rect">
+            <a:avLst/>
+          </a:prstGeom>
+        </p:spPr>
+      </p:pic>
     </p:spTree>
   </p:cSld>
   <p:clrMapOvr>

</xml_diff>